<commit_message>
docs: refresh dashboard screenshots in README and deck (Oct 10, 2026)
Re-capture all three Power BI page screenshots from the redesigned
report and swap them into assets/, the README pages section, and
slides 9-11 of the presentation (aspect-ratio preserved).

Generated with Codebuff 🤖
Co-Authored-By: Codebuff <noreply@codebuff.com>
</commit_message>
<xml_diff>
--- a/Healthcare_Analytics_Lakehouse_Presentation.pptx
+++ b/Healthcare_Analytics_Lakehouse_Presentation.pptx
@@ -1947,6 +1947,260 @@
 
 <file path=ppt/slides/slide10.xml><?xml version="1.0" encoding="utf-8"?>
 <p:sld xmlns:a="http://schemas.openxmlformats.org/drawingml/2006/main" xmlns:r="http://schemas.openxmlformats.org/officeDocument/2006/relationships" xmlns:p="http://schemas.openxmlformats.org/presentationml/2006/main">
+  <p:cSld name="Slide 9">
+    <p:bg>
+      <p:bgPr>
+        <a:solidFill>
+          <a:srgbClr val="FFFFFF"/>
+        </a:solidFill>
+        <a:effectLst/>
+      </p:bgPr>
+    </p:bg>
+    <p:spTree>
+      <p:nvGrpSpPr>
+        <p:cNvPr id="1" name=""/>
+        <p:cNvGrpSpPr/>
+        <p:nvPr/>
+      </p:nvGrpSpPr>
+      <p:grpSpPr>
+        <a:xfrm>
+          <a:off x="0" y="0"/>
+          <a:ext cx="0" cy="0"/>
+          <a:chOff x="0" y="0"/>
+          <a:chExt cx="0" cy="0"/>
+        </a:xfrm>
+      </p:grpSpPr>
+      <p:sp>
+        <p:nvSpPr>
+          <p:cNvPr id="2" name="Text 0"/>
+          <p:cNvSpPr txBox="1"/>
+          <p:nvPr/>
+        </p:nvSpPr>
+        <p:spPr>
+          <a:xfrm>
+            <a:off x="548640" y="365760"/>
+            <a:ext cx="7315200" cy="320040"/>
+          </a:xfrm>
+          <a:prstGeom prst="rect">
+            <a:avLst/>
+          </a:prstGeom>
+          <a:noFill/>
+          <a:ln/>
+        </p:spPr>
+        <p:txBody>
+          <a:bodyPr wrap="square" rtlCol="0" anchor="ctr"/>
+          <a:lstStyle/>
+          <a:p>
+            <a:pPr marL="0" indent="0">
+              <a:buNone/>
+            </a:pPr>
+            <a:r>
+              <a:rPr lang="en-US" sz="1200" b="1" kern="0" spc="200" dirty="0">
+                <a:solidFill>
+                  <a:srgbClr val="00A896"/>
+                </a:solidFill>
+                <a:latin typeface="Calibri" pitchFamily="34" charset="0"/>
+                <a:ea typeface="Calibri" pitchFamily="34" charset="-122"/>
+                <a:cs typeface="Calibri" pitchFamily="34" charset="-120"/>
+              </a:rPr>
+              <a:t>POWER BI — PAGE 2</a:t>
+            </a:r>
+            <a:endParaRPr lang="en-US" sz="1200" dirty="0"/>
+          </a:p>
+        </p:txBody>
+      </p:sp>
+      <p:sp>
+        <p:nvSpPr>
+          <p:cNvPr id="3" name="Text 1"/>
+          <p:cNvSpPr txBox="1"/>
+          <p:nvPr/>
+        </p:nvSpPr>
+        <p:spPr>
+          <a:xfrm>
+            <a:off x="548640" y="640080"/>
+            <a:ext cx="10515600" cy="640080"/>
+          </a:xfrm>
+          <a:prstGeom prst="rect">
+            <a:avLst/>
+          </a:prstGeom>
+          <a:noFill/>
+          <a:ln/>
+        </p:spPr>
+        <p:txBody>
+          <a:bodyPr wrap="square" rtlCol="0" anchor="ctr"/>
+          <a:lstStyle/>
+          <a:p>
+            <a:pPr marL="0" indent="0">
+              <a:buNone/>
+            </a:pPr>
+            <a:r>
+              <a:rPr lang="en-US" sz="3000" b="1" dirty="0">
+                <a:solidFill>
+                  <a:srgbClr val="1A2E2E"/>
+                </a:solidFill>
+                <a:latin typeface="Cambria" pitchFamily="34" charset="0"/>
+                <a:ea typeface="Cambria" pitchFamily="34" charset="-122"/>
+                <a:cs typeface="Cambria" pitchFamily="34" charset="-120"/>
+              </a:rPr>
+              <a:t>Financial Integrity &amp; Billing Operations</a:t>
+            </a:r>
+            <a:endParaRPr lang="en-US" sz="3000" dirty="0"/>
+          </a:p>
+        </p:txBody>
+      </p:sp>
+      <p:sp>
+        <p:nvSpPr>
+          <p:cNvPr id="4" name="Shape 2"/>
+          <p:cNvSpPr/>
+          <p:nvPr/>
+        </p:nvSpPr>
+        <p:spPr>
+          <a:xfrm>
+            <a:off x="502920" y="1600200"/>
+            <a:ext cx="11201400" cy="4617720"/>
+          </a:xfrm>
+          <a:prstGeom prst="roundRect">
+            <a:avLst>
+              <a:gd name="adj" fmla="val 792"/>
+            </a:avLst>
+          </a:prstGeom>
+          <a:solidFill>
+            <a:srgbClr val="FFFFFF"/>
+          </a:solidFill>
+          <a:ln w="19050">
+            <a:solidFill>
+              <a:srgbClr val="DCE9E9"/>
+            </a:solidFill>
+            <a:prstDash val="solid"/>
+          </a:ln>
+          <a:effectLst>
+            <a:outerShdw blurRad="101600" dist="38100" dir="5400000" algn="bl" rotWithShape="0">
+              <a:srgbClr val="1A2E2E">
+                <a:alpha val="18000"/>
+              </a:srgbClr>
+            </a:outerShdw>
+          </a:effectLst>
+        </p:spPr>
+        <p:txBody>
+          <a:bodyPr/>
+          <a:lstStyle/>
+          <a:p>
+            <a:endParaRPr lang="en-US"/>
+          </a:p>
+        </p:txBody>
+      </p:sp>
+      <p:sp>
+        <p:nvSpPr>
+          <p:cNvPr id="6" name="Text 3"/>
+          <p:cNvSpPr txBox="1"/>
+          <p:nvPr/>
+        </p:nvSpPr>
+        <p:spPr>
+          <a:xfrm>
+            <a:off x="548640" y="6537960"/>
+            <a:ext cx="7315200" cy="274320"/>
+          </a:xfrm>
+          <a:prstGeom prst="rect">
+            <a:avLst/>
+          </a:prstGeom>
+          <a:noFill/>
+          <a:ln/>
+        </p:spPr>
+        <p:txBody>
+          <a:bodyPr wrap="square" rtlCol="0" anchor="ctr"/>
+          <a:lstStyle/>
+          <a:p>
+            <a:pPr marL="0" indent="0">
+              <a:buNone/>
+            </a:pPr>
+            <a:r>
+              <a:rPr lang="en-US" sz="900" dirty="0">
+                <a:solidFill>
+                  <a:srgbClr val="5A6B6C"/>
+                </a:solidFill>
+                <a:latin typeface="Calibri" pitchFamily="34" charset="0"/>
+                <a:ea typeface="Calibri" pitchFamily="34" charset="-122"/>
+                <a:cs typeface="Calibri" pitchFamily="34" charset="-120"/>
+              </a:rPr>
+              <a:t>Healthcare Analytics &amp; Lakehouse Platform</a:t>
+            </a:r>
+            <a:endParaRPr lang="en-US" sz="900" dirty="0"/>
+          </a:p>
+        </p:txBody>
+      </p:sp>
+      <p:sp>
+        <p:nvSpPr>
+          <p:cNvPr id="7" name="Text 4"/>
+          <p:cNvSpPr txBox="1"/>
+          <p:nvPr/>
+        </p:nvSpPr>
+        <p:spPr>
+          <a:xfrm>
+            <a:off x="11521440" y="6537960"/>
+            <a:ext cx="457200" cy="274320"/>
+          </a:xfrm>
+          <a:prstGeom prst="rect">
+            <a:avLst/>
+          </a:prstGeom>
+          <a:noFill/>
+          <a:ln/>
+        </p:spPr>
+        <p:txBody>
+          <a:bodyPr wrap="square" rtlCol="0" anchor="ctr"/>
+          <a:lstStyle/>
+          <a:p>
+            <a:pPr marL="0" indent="0" algn="r">
+              <a:buNone/>
+            </a:pPr>
+            <a:r>
+              <a:rPr lang="en-US" sz="900" dirty="0">
+                <a:solidFill>
+                  <a:srgbClr val="5A6B6C"/>
+                </a:solidFill>
+                <a:latin typeface="Calibri" pitchFamily="34" charset="0"/>
+                <a:ea typeface="Calibri" pitchFamily="34" charset="-122"/>
+                <a:cs typeface="Calibri" pitchFamily="34" charset="-120"/>
+              </a:rPr>
+              <a:t>10</a:t>
+            </a:r>
+            <a:endParaRPr lang="en-US" sz="900" dirty="0"/>
+          </a:p>
+        </p:txBody>
+      </p:sp>
+      <p:pic>
+        <p:nvPicPr>
+          <p:cNvPr id="8" name="Picture 7" descr="dashboard_page2_financial.png"/>
+          <p:cNvPicPr>
+            <a:picLocks noChangeAspect="1"/>
+          </p:cNvPicPr>
+          <p:nvPr/>
+        </p:nvPicPr>
+        <p:blipFill>
+          <a:blip r:embed="rId4"/>
+          <a:stretch>
+            <a:fillRect/>
+          </a:stretch>
+        </p:blipFill>
+        <p:spPr>
+          <a:xfrm>
+            <a:off x="2355758" y="1783080"/>
+            <a:ext cx="7495723" cy="4251960"/>
+          </a:xfrm>
+          <a:prstGeom prst="rect">
+            <a:avLst/>
+          </a:prstGeom>
+        </p:spPr>
+      </p:pic>
+    </p:spTree>
+  </p:cSld>
+  <p:clrMapOvr>
+    <a:masterClrMapping/>
+  </p:clrMapOvr>
+</p:sld>
+</file>
+
+<file path=ppt/slides/slide11.xml><?xml version="1.0" encoding="utf-8"?>
+<p:sld xmlns:a="http://schemas.openxmlformats.org/drawingml/2006/main" xmlns:r="http://schemas.openxmlformats.org/officeDocument/2006/relationships" xmlns:p="http://schemas.openxmlformats.org/presentationml/2006/main">
   <p:cSld name="Slide 10">
     <p:bg>
       <p:bgPr>
@@ -2089,108 +2343,108 @@
           </a:p>
         </p:txBody>
       </p:sp>
+      <p:sp>
+        <p:nvSpPr>
+          <p:cNvPr id="6" name="Text 3"/>
+          <p:cNvSpPr txBox="1"/>
+          <p:nvPr/>
+        </p:nvSpPr>
+        <p:spPr>
+          <a:xfrm>
+            <a:off x="548640" y="6537960"/>
+            <a:ext cx="7315200" cy="274320"/>
+          </a:xfrm>
+          <a:prstGeom prst="rect">
+            <a:avLst/>
+          </a:prstGeom>
+          <a:noFill/>
+          <a:ln/>
+        </p:spPr>
+        <p:txBody>
+          <a:bodyPr wrap="square" rtlCol="0" anchor="ctr"/>
+          <a:lstStyle/>
+          <a:p>
+            <a:pPr marL="0" indent="0">
+              <a:buNone/>
+            </a:pPr>
+            <a:r>
+              <a:rPr lang="en-US" sz="900" dirty="0">
+                <a:solidFill>
+                  <a:srgbClr val="5A6B6C"/>
+                </a:solidFill>
+                <a:latin typeface="Calibri" pitchFamily="34" charset="0"/>
+                <a:ea typeface="Calibri" pitchFamily="34" charset="-122"/>
+                <a:cs typeface="Calibri" pitchFamily="34" charset="-120"/>
+              </a:rPr>
+              <a:t>Healthcare Analytics &amp; Lakehouse Platform</a:t>
+            </a:r>
+            <a:endParaRPr lang="en-US" sz="900" dirty="0"/>
+          </a:p>
+        </p:txBody>
+      </p:sp>
+      <p:sp>
+        <p:nvSpPr>
+          <p:cNvPr id="7" name="Text 4"/>
+          <p:cNvSpPr txBox="1"/>
+          <p:nvPr/>
+        </p:nvSpPr>
+        <p:spPr>
+          <a:xfrm>
+            <a:off x="11521440" y="6537960"/>
+            <a:ext cx="457200" cy="274320"/>
+          </a:xfrm>
+          <a:prstGeom prst="rect">
+            <a:avLst/>
+          </a:prstGeom>
+          <a:noFill/>
+          <a:ln/>
+        </p:spPr>
+        <p:txBody>
+          <a:bodyPr wrap="square" rtlCol="0" anchor="ctr"/>
+          <a:lstStyle/>
+          <a:p>
+            <a:pPr marL="0" indent="0" algn="r">
+              <a:buNone/>
+            </a:pPr>
+            <a:r>
+              <a:rPr lang="en-US" sz="900" dirty="0">
+                <a:solidFill>
+                  <a:srgbClr val="5A6B6C"/>
+                </a:solidFill>
+                <a:latin typeface="Calibri" pitchFamily="34" charset="0"/>
+                <a:ea typeface="Calibri" pitchFamily="34" charset="-122"/>
+                <a:cs typeface="Calibri" pitchFamily="34" charset="-120"/>
+              </a:rPr>
+              <a:t>11</a:t>
+            </a:r>
+            <a:endParaRPr lang="en-US" sz="900" dirty="0"/>
+          </a:p>
+        </p:txBody>
+      </p:sp>
       <p:pic>
         <p:nvPicPr>
-          <p:cNvPr id="5" name="Image 0" descr="assets/dashboard_page3_operational.png"/>
+          <p:cNvPr id="8" name="Picture 7" descr="dashboard_page3_operational.png"/>
           <p:cNvPicPr>
             <a:picLocks noChangeAspect="1"/>
           </p:cNvPicPr>
           <p:nvPr/>
         </p:nvPicPr>
         <p:blipFill>
-          <a:blip r:embed="rId3"/>
+          <a:blip r:embed="rId4"/>
           <a:stretch>
             <a:fillRect/>
           </a:stretch>
         </p:blipFill>
         <p:spPr>
           <a:xfrm>
-            <a:off x="685800" y="1783080"/>
-            <a:ext cx="10835640" cy="4251960"/>
+            <a:off x="2322570" y="1783080"/>
+            <a:ext cx="7562099" cy="4251960"/>
           </a:xfrm>
           <a:prstGeom prst="rect">
             <a:avLst/>
           </a:prstGeom>
         </p:spPr>
       </p:pic>
-      <p:sp>
-        <p:nvSpPr>
-          <p:cNvPr id="6" name="Text 3"/>
-          <p:cNvSpPr txBox="1"/>
-          <p:nvPr/>
-        </p:nvSpPr>
-        <p:spPr>
-          <a:xfrm>
-            <a:off x="548640" y="6537960"/>
-            <a:ext cx="7315200" cy="274320"/>
-          </a:xfrm>
-          <a:prstGeom prst="rect">
-            <a:avLst/>
-          </a:prstGeom>
-          <a:noFill/>
-          <a:ln/>
-        </p:spPr>
-        <p:txBody>
-          <a:bodyPr wrap="square" rtlCol="0" anchor="ctr"/>
-          <a:lstStyle/>
-          <a:p>
-            <a:pPr marL="0" indent="0">
-              <a:buNone/>
-            </a:pPr>
-            <a:r>
-              <a:rPr lang="en-US" sz="900" dirty="0">
-                <a:solidFill>
-                  <a:srgbClr val="5A6B6C"/>
-                </a:solidFill>
-                <a:latin typeface="Calibri" pitchFamily="34" charset="0"/>
-                <a:ea typeface="Calibri" pitchFamily="34" charset="-122"/>
-                <a:cs typeface="Calibri" pitchFamily="34" charset="-120"/>
-              </a:rPr>
-              <a:t>Healthcare Analytics &amp; Lakehouse Platform</a:t>
-            </a:r>
-            <a:endParaRPr lang="en-US" sz="900" dirty="0"/>
-          </a:p>
-        </p:txBody>
-      </p:sp>
-      <p:sp>
-        <p:nvSpPr>
-          <p:cNvPr id="7" name="Text 4"/>
-          <p:cNvSpPr txBox="1"/>
-          <p:nvPr/>
-        </p:nvSpPr>
-        <p:spPr>
-          <a:xfrm>
-            <a:off x="11521440" y="6537960"/>
-            <a:ext cx="457200" cy="274320"/>
-          </a:xfrm>
-          <a:prstGeom prst="rect">
-            <a:avLst/>
-          </a:prstGeom>
-          <a:noFill/>
-          <a:ln/>
-        </p:spPr>
-        <p:txBody>
-          <a:bodyPr wrap="square" rtlCol="0" anchor="ctr"/>
-          <a:lstStyle/>
-          <a:p>
-            <a:pPr marL="0" indent="0" algn="r">
-              <a:buNone/>
-            </a:pPr>
-            <a:r>
-              <a:rPr lang="en-US" sz="900" dirty="0">
-                <a:solidFill>
-                  <a:srgbClr val="5A6B6C"/>
-                </a:solidFill>
-                <a:latin typeface="Calibri" pitchFamily="34" charset="0"/>
-                <a:ea typeface="Calibri" pitchFamily="34" charset="-122"/>
-                <a:cs typeface="Calibri" pitchFamily="34" charset="-120"/>
-              </a:rPr>
-              <a:t>11</a:t>
-            </a:r>
-            <a:endParaRPr lang="en-US" sz="900" dirty="0"/>
-          </a:p>
-        </p:txBody>
-      </p:sp>
     </p:spTree>
   </p:cSld>
   <p:clrMapOvr>
@@ -2199,7 +2453,7 @@
 </p:sld>
 </file>
 
-<file path=ppt/slides/slide11.xml><?xml version="1.0" encoding="utf-8"?>
+<file path=ppt/slides/slide12.xml><?xml version="1.0" encoding="utf-8"?>
 <p:sld xmlns:a="http://schemas.openxmlformats.org/drawingml/2006/main" xmlns:r="http://schemas.openxmlformats.org/officeDocument/2006/relationships" xmlns:p="http://schemas.openxmlformats.org/presentationml/2006/main">
   <p:cSld name="Slide 11">
     <p:bg>
@@ -2892,7 +3146,7 @@
 </p:sld>
 </file>
 
-<file path=ppt/slides/slide12.xml><?xml version="1.0" encoding="utf-8"?>
+<file path=ppt/slides/slide13.xml><?xml version="1.0" encoding="utf-8"?>
 <p:sld xmlns:a="http://schemas.openxmlformats.org/drawingml/2006/main" xmlns:r="http://schemas.openxmlformats.org/officeDocument/2006/relationships" xmlns:p="http://schemas.openxmlformats.org/presentationml/2006/main">
   <p:cSld name="Slide 12">
     <p:bg>
@@ -3171,867 +3425,6 @@
               <a:t>Mo Amer — Healthcare Analytics &amp; Lakehouse Platform Capstone</a:t>
             </a:r>
             <a:endParaRPr lang="en-US" sz="1100" dirty="0"/>
-          </a:p>
-        </p:txBody>
-      </p:sp>
-    </p:spTree>
-  </p:cSld>
-  <p:clrMapOvr>
-    <a:masterClrMapping/>
-  </p:clrMapOvr>
-</p:sld>
-</file>
-
-<file path=ppt/slides/slide13.xml><?xml version="1.0" encoding="utf-8"?>
-<p:sld xmlns:a="http://schemas.openxmlformats.org/drawingml/2006/main" xmlns:p="http://schemas.openxmlformats.org/presentationml/2006/main" xmlns:r="http://schemas.openxmlformats.org/officeDocument/2006/relationships">
-  <p:cSld>
-    <p:spTree>
-      <p:nvGrpSpPr>
-        <p:cNvPr id="1" name=""/>
-        <p:cNvGrpSpPr/>
-        <p:nvPr/>
-      </p:nvGrpSpPr>
-      <p:grpSpPr/>
-      <p:sp>
-        <p:nvSpPr>
-          <p:cNvPr id="2" name="TextBox 1"/>
-          <p:cNvSpPr txBox="1"/>
-          <p:nvPr/>
-        </p:nvSpPr>
-        <p:spPr>
-          <a:xfrm>
-            <a:off x="548640" y="365760"/>
-            <a:ext cx="7315200" cy="320040"/>
-          </a:xfrm>
-          <a:prstGeom prst="rect">
-            <a:avLst/>
-          </a:prstGeom>
-          <a:noFill/>
-        </p:spPr>
-        <p:txBody>
-          <a:bodyPr wrap="square" lIns="0" rIns="0" tIns="0" bIns="0">
-            <a:spAutoFit/>
-          </a:bodyPr>
-          <a:lstStyle/>
-          <a:p>
-            <a:pPr algn="l"/>
-            <a:r>
-              <a:rPr sz="1200" b="1">
-                <a:solidFill>
-                  <a:srgbClr val="00A896"/>
-                </a:solidFill>
-                <a:latin typeface="Calibri"/>
-              </a:rPr>
-              <a:t>WHAT'S NEW</a:t>
-            </a:r>
-          </a:p>
-        </p:txBody>
-      </p:sp>
-      <p:sp>
-        <p:nvSpPr>
-          <p:cNvPr id="3" name="TextBox 2"/>
-          <p:cNvSpPr txBox="1"/>
-          <p:nvPr/>
-        </p:nvSpPr>
-        <p:spPr>
-          <a:xfrm>
-            <a:off x="548640" y="640080"/>
-            <a:ext cx="10515600" cy="640080"/>
-          </a:xfrm>
-          <a:prstGeom prst="rect">
-            <a:avLst/>
-          </a:prstGeom>
-          <a:noFill/>
-        </p:spPr>
-        <p:txBody>
-          <a:bodyPr wrap="square" lIns="0" rIns="0" tIns="0" bIns="0">
-            <a:spAutoFit/>
-          </a:bodyPr>
-          <a:lstStyle/>
-          <a:p>
-            <a:pPr algn="l"/>
-            <a:r>
-              <a:rPr sz="3000" b="1">
-                <a:solidFill>
-                  <a:srgbClr val="1A2E2E"/>
-                </a:solidFill>
-                <a:latin typeface="Cambria"/>
-              </a:rPr>
-              <a:t>Updates — October 2026</a:t>
-            </a:r>
-          </a:p>
-        </p:txBody>
-      </p:sp>
-      <p:sp>
-        <p:nvSpPr>
-          <p:cNvPr id="4" name="Rectangle 3"/>
-          <p:cNvSpPr/>
-          <p:nvPr/>
-        </p:nvSpPr>
-        <p:spPr>
-          <a:xfrm>
-            <a:off x="548640" y="1691640"/>
-            <a:ext cx="2606040" cy="3017520"/>
-          </a:xfrm>
-          <a:prstGeom prst="rect">
-            <a:avLst/>
-          </a:prstGeom>
-          <a:solidFill>
-            <a:srgbClr val="F4F8F8"/>
-          </a:solidFill>
-          <a:ln>
-            <a:noFill/>
-          </a:ln>
-          <a:effectLst/>
-        </p:spPr>
-        <p:style>
-          <a:lnRef idx="1">
-            <a:schemeClr val="accent1"/>
-          </a:lnRef>
-          <a:fillRef idx="3">
-            <a:schemeClr val="accent1"/>
-          </a:fillRef>
-          <a:effectRef idx="2">
-            <a:schemeClr val="accent1"/>
-          </a:effectRef>
-          <a:fontRef idx="minor">
-            <a:schemeClr val="lt1"/>
-          </a:fontRef>
-        </p:style>
-        <p:txBody>
-          <a:bodyPr rtlCol="0" anchor="ctr"/>
-          <a:lstStyle/>
-          <a:p>
-            <a:pPr algn="ctr"/>
-          </a:p>
-        </p:txBody>
-      </p:sp>
-      <p:sp>
-        <p:nvSpPr>
-          <p:cNvPr id="5" name="Rectangle 4"/>
-          <p:cNvSpPr/>
-          <p:nvPr/>
-        </p:nvSpPr>
-        <p:spPr>
-          <a:xfrm>
-            <a:off x="777240" y="1965960"/>
-            <a:ext cx="502920" cy="502920"/>
-          </a:xfrm>
-          <a:prstGeom prst="rect">
-            <a:avLst/>
-          </a:prstGeom>
-          <a:solidFill>
-            <a:srgbClr val="028090"/>
-          </a:solidFill>
-          <a:ln>
-            <a:noFill/>
-          </a:ln>
-          <a:effectLst/>
-        </p:spPr>
-        <p:style>
-          <a:lnRef idx="1">
-            <a:schemeClr val="accent1"/>
-          </a:lnRef>
-          <a:fillRef idx="3">
-            <a:schemeClr val="accent1"/>
-          </a:fillRef>
-          <a:effectRef idx="2">
-            <a:schemeClr val="accent1"/>
-          </a:effectRef>
-          <a:fontRef idx="minor">
-            <a:schemeClr val="lt1"/>
-          </a:fontRef>
-        </p:style>
-        <p:txBody>
-          <a:bodyPr rtlCol="0" anchor="ctr"/>
-          <a:lstStyle/>
-          <a:p>
-            <a:pPr algn="ctr"/>
-            <a:r>
-              <a:rPr sz="2000" b="1">
-                <a:solidFill>
-                  <a:srgbClr val="FFFFFF"/>
-                </a:solidFill>
-                <a:latin typeface="Cambria"/>
-              </a:rPr>
-              <a:t>1</a:t>
-            </a:r>
-          </a:p>
-        </p:txBody>
-      </p:sp>
-      <p:sp>
-        <p:nvSpPr>
-          <p:cNvPr id="6" name="TextBox 5"/>
-          <p:cNvSpPr txBox="1"/>
-          <p:nvPr/>
-        </p:nvSpPr>
-        <p:spPr>
-          <a:xfrm>
-            <a:off x="777240" y="2606040"/>
-            <a:ext cx="2148840" cy="365760"/>
-          </a:xfrm>
-          <a:prstGeom prst="rect">
-            <a:avLst/>
-          </a:prstGeom>
-          <a:noFill/>
-        </p:spPr>
-        <p:txBody>
-          <a:bodyPr wrap="square" lIns="0" rIns="0" tIns="0" bIns="0">
-            <a:spAutoFit/>
-          </a:bodyPr>
-          <a:lstStyle/>
-          <a:p>
-            <a:pPr algn="l"/>
-            <a:r>
-              <a:rPr sz="1800" b="1">
-                <a:solidFill>
-                  <a:srgbClr val="1A2E2E"/>
-                </a:solidFill>
-                <a:latin typeface="Cambria"/>
-              </a:rPr>
-              <a:t>Report Redesign</a:t>
-            </a:r>
-          </a:p>
-        </p:txBody>
-      </p:sp>
-      <p:sp>
-        <p:nvSpPr>
-          <p:cNvPr id="7" name="TextBox 6"/>
-          <p:cNvSpPr txBox="1"/>
-          <p:nvPr/>
-        </p:nvSpPr>
-        <p:spPr>
-          <a:xfrm>
-            <a:off x="777240" y="3017520"/>
-            <a:ext cx="2148840" cy="1463040"/>
-          </a:xfrm>
-          <a:prstGeom prst="rect">
-            <a:avLst/>
-          </a:prstGeom>
-          <a:noFill/>
-        </p:spPr>
-        <p:txBody>
-          <a:bodyPr wrap="square" lIns="0" rIns="0" tIns="0" bIns="0">
-            <a:spAutoFit/>
-          </a:bodyPr>
-          <a:lstStyle/>
-          <a:p>
-            <a:pPr algn="l"/>
-            <a:r>
-              <a:rPr sz="1200" b="0">
-                <a:solidFill>
-                  <a:srgbClr val="5A6B6C"/>
-                </a:solidFill>
-                <a:latin typeface="Calibri"/>
-              </a:rPr>
-              <a:t>White branded header on all three pages, a dedicated Filters panel, KPI cards with visible labels, $K data labels, and Refresh / Clear Filters controls.</a:t>
-            </a:r>
-          </a:p>
-        </p:txBody>
-      </p:sp>
-      <p:sp>
-        <p:nvSpPr>
-          <p:cNvPr id="8" name="Rectangle 7"/>
-          <p:cNvSpPr/>
-          <p:nvPr/>
-        </p:nvSpPr>
-        <p:spPr>
-          <a:xfrm>
-            <a:off x="3383280" y="1691640"/>
-            <a:ext cx="2606040" cy="3017520"/>
-          </a:xfrm>
-          <a:prstGeom prst="rect">
-            <a:avLst/>
-          </a:prstGeom>
-          <a:solidFill>
-            <a:srgbClr val="F4F8F8"/>
-          </a:solidFill>
-          <a:ln>
-            <a:noFill/>
-          </a:ln>
-          <a:effectLst/>
-        </p:spPr>
-        <p:style>
-          <a:lnRef idx="1">
-            <a:schemeClr val="accent1"/>
-          </a:lnRef>
-          <a:fillRef idx="3">
-            <a:schemeClr val="accent1"/>
-          </a:fillRef>
-          <a:effectRef idx="2">
-            <a:schemeClr val="accent1"/>
-          </a:effectRef>
-          <a:fontRef idx="minor">
-            <a:schemeClr val="lt1"/>
-          </a:fontRef>
-        </p:style>
-        <p:txBody>
-          <a:bodyPr rtlCol="0" anchor="ctr"/>
-          <a:lstStyle/>
-          <a:p>
-            <a:pPr algn="ctr"/>
-          </a:p>
-        </p:txBody>
-      </p:sp>
-      <p:sp>
-        <p:nvSpPr>
-          <p:cNvPr id="9" name="Rectangle 8"/>
-          <p:cNvSpPr/>
-          <p:nvPr/>
-        </p:nvSpPr>
-        <p:spPr>
-          <a:xfrm>
-            <a:off x="3611880" y="1965960"/>
-            <a:ext cx="502920" cy="502920"/>
-          </a:xfrm>
-          <a:prstGeom prst="rect">
-            <a:avLst/>
-          </a:prstGeom>
-          <a:solidFill>
-            <a:srgbClr val="028090"/>
-          </a:solidFill>
-          <a:ln>
-            <a:noFill/>
-          </a:ln>
-          <a:effectLst/>
-        </p:spPr>
-        <p:style>
-          <a:lnRef idx="1">
-            <a:schemeClr val="accent1"/>
-          </a:lnRef>
-          <a:fillRef idx="3">
-            <a:schemeClr val="accent1"/>
-          </a:fillRef>
-          <a:effectRef idx="2">
-            <a:schemeClr val="accent1"/>
-          </a:effectRef>
-          <a:fontRef idx="minor">
-            <a:schemeClr val="lt1"/>
-          </a:fontRef>
-        </p:style>
-        <p:txBody>
-          <a:bodyPr rtlCol="0" anchor="ctr"/>
-          <a:lstStyle/>
-          <a:p>
-            <a:pPr algn="ctr"/>
-            <a:r>
-              <a:rPr sz="2000" b="1">
-                <a:solidFill>
-                  <a:srgbClr val="FFFFFF"/>
-                </a:solidFill>
-                <a:latin typeface="Cambria"/>
-              </a:rPr>
-              <a:t>2</a:t>
-            </a:r>
-          </a:p>
-        </p:txBody>
-      </p:sp>
-      <p:sp>
-        <p:nvSpPr>
-          <p:cNvPr id="10" name="TextBox 9"/>
-          <p:cNvSpPr txBox="1"/>
-          <p:nvPr/>
-        </p:nvSpPr>
-        <p:spPr>
-          <a:xfrm>
-            <a:off x="3611880" y="2606040"/>
-            <a:ext cx="2148840" cy="365760"/>
-          </a:xfrm>
-          <a:prstGeom prst="rect">
-            <a:avLst/>
-          </a:prstGeom>
-          <a:noFill/>
-        </p:spPr>
-        <p:txBody>
-          <a:bodyPr wrap="square" lIns="0" rIns="0" tIns="0" bIns="0">
-            <a:spAutoFit/>
-          </a:bodyPr>
-          <a:lstStyle/>
-          <a:p>
-            <a:pPr algn="l"/>
-            <a:r>
-              <a:rPr sz="1800" b="1">
-                <a:solidFill>
-                  <a:srgbClr val="1A2E2E"/>
-                </a:solidFill>
-                <a:latin typeface="Cambria"/>
-              </a:rPr>
-              <a:t>Live Refresh Stamp</a:t>
-            </a:r>
-          </a:p>
-        </p:txBody>
-      </p:sp>
-      <p:sp>
-        <p:nvSpPr>
-          <p:cNvPr id="11" name="TextBox 10"/>
-          <p:cNvSpPr txBox="1"/>
-          <p:nvPr/>
-        </p:nvSpPr>
-        <p:spPr>
-          <a:xfrm>
-            <a:off x="3611880" y="3017520"/>
-            <a:ext cx="2148840" cy="1463040"/>
-          </a:xfrm>
-          <a:prstGeom prst="rect">
-            <a:avLst/>
-          </a:prstGeom>
-          <a:noFill/>
-        </p:spPr>
-        <p:txBody>
-          <a:bodyPr wrap="square" lIns="0" rIns="0" tIns="0" bIns="0">
-            <a:spAutoFit/>
-          </a:bodyPr>
-          <a:lstStyle/>
-          <a:p>
-            <a:pPr algn="l"/>
-            <a:r>
-              <a:rPr sz="1200" b="0">
-                <a:solidFill>
-                  <a:srgbClr val="5A6B6C"/>
-                </a:solidFill>
-                <a:latin typeface="Calibri"/>
-              </a:rPr>
-              <a:t>A new 'Data Last Refreshed' DAX measure (FORMAT(NOW())) replaces the static timestamp and updates automatically on every model refresh.</a:t>
-            </a:r>
-          </a:p>
-        </p:txBody>
-      </p:sp>
-      <p:sp>
-        <p:nvSpPr>
-          <p:cNvPr id="12" name="Rectangle 11"/>
-          <p:cNvSpPr/>
-          <p:nvPr/>
-        </p:nvSpPr>
-        <p:spPr>
-          <a:xfrm>
-            <a:off x="6217920" y="1691640"/>
-            <a:ext cx="2606040" cy="3017520"/>
-          </a:xfrm>
-          <a:prstGeom prst="rect">
-            <a:avLst/>
-          </a:prstGeom>
-          <a:solidFill>
-            <a:srgbClr val="F4F8F8"/>
-          </a:solidFill>
-          <a:ln>
-            <a:noFill/>
-          </a:ln>
-          <a:effectLst/>
-        </p:spPr>
-        <p:style>
-          <a:lnRef idx="1">
-            <a:schemeClr val="accent1"/>
-          </a:lnRef>
-          <a:fillRef idx="3">
-            <a:schemeClr val="accent1"/>
-          </a:fillRef>
-          <a:effectRef idx="2">
-            <a:schemeClr val="accent1"/>
-          </a:effectRef>
-          <a:fontRef idx="minor">
-            <a:schemeClr val="lt1"/>
-          </a:fontRef>
-        </p:style>
-        <p:txBody>
-          <a:bodyPr rtlCol="0" anchor="ctr"/>
-          <a:lstStyle/>
-          <a:p>
-            <a:pPr algn="ctr"/>
-          </a:p>
-        </p:txBody>
-      </p:sp>
-      <p:sp>
-        <p:nvSpPr>
-          <p:cNvPr id="13" name="Rectangle 12"/>
-          <p:cNvSpPr/>
-          <p:nvPr/>
-        </p:nvSpPr>
-        <p:spPr>
-          <a:xfrm>
-            <a:off x="6446520" y="1965960"/>
-            <a:ext cx="502920" cy="502920"/>
-          </a:xfrm>
-          <a:prstGeom prst="rect">
-            <a:avLst/>
-          </a:prstGeom>
-          <a:solidFill>
-            <a:srgbClr val="028090"/>
-          </a:solidFill>
-          <a:ln>
-            <a:noFill/>
-          </a:ln>
-          <a:effectLst/>
-        </p:spPr>
-        <p:style>
-          <a:lnRef idx="1">
-            <a:schemeClr val="accent1"/>
-          </a:lnRef>
-          <a:fillRef idx="3">
-            <a:schemeClr val="accent1"/>
-          </a:fillRef>
-          <a:effectRef idx="2">
-            <a:schemeClr val="accent1"/>
-          </a:effectRef>
-          <a:fontRef idx="minor">
-            <a:schemeClr val="lt1"/>
-          </a:fontRef>
-        </p:style>
-        <p:txBody>
-          <a:bodyPr rtlCol="0" anchor="ctr"/>
-          <a:lstStyle/>
-          <a:p>
-            <a:pPr algn="ctr"/>
-            <a:r>
-              <a:rPr sz="2000" b="1">
-                <a:solidFill>
-                  <a:srgbClr val="FFFFFF"/>
-                </a:solidFill>
-                <a:latin typeface="Cambria"/>
-              </a:rPr>
-              <a:t>3</a:t>
-            </a:r>
-          </a:p>
-        </p:txBody>
-      </p:sp>
-      <p:sp>
-        <p:nvSpPr>
-          <p:cNvPr id="14" name="TextBox 13"/>
-          <p:cNvSpPr txBox="1"/>
-          <p:nvPr/>
-        </p:nvSpPr>
-        <p:spPr>
-          <a:xfrm>
-            <a:off x="6446520" y="2606040"/>
-            <a:ext cx="2148840" cy="365760"/>
-          </a:xfrm>
-          <a:prstGeom prst="rect">
-            <a:avLst/>
-          </a:prstGeom>
-          <a:noFill/>
-        </p:spPr>
-        <p:txBody>
-          <a:bodyPr wrap="square" lIns="0" rIns="0" tIns="0" bIns="0">
-            <a:spAutoFit/>
-          </a:bodyPr>
-          <a:lstStyle/>
-          <a:p>
-            <a:pPr algn="l"/>
-            <a:r>
-              <a:rPr sz="1800" b="1">
-                <a:solidFill>
-                  <a:srgbClr val="1A2E2E"/>
-                </a:solidFill>
-                <a:latin typeface="Cambria"/>
-              </a:rPr>
-              <a:t>Gold → Neon Serving</a:t>
-            </a:r>
-          </a:p>
-        </p:txBody>
-      </p:sp>
-      <p:sp>
-        <p:nvSpPr>
-          <p:cNvPr id="15" name="TextBox 14"/>
-          <p:cNvSpPr txBox="1"/>
-          <p:nvPr/>
-        </p:nvSpPr>
-        <p:spPr>
-          <a:xfrm>
-            <a:off x="6446520" y="3017520"/>
-            <a:ext cx="2148840" cy="1463040"/>
-          </a:xfrm>
-          <a:prstGeom prst="rect">
-            <a:avLst/>
-          </a:prstGeom>
-          <a:noFill/>
-        </p:spPr>
-        <p:txBody>
-          <a:bodyPr wrap="square" lIns="0" rIns="0" tIns="0" bIns="0">
-            <a:spAutoFit/>
-          </a:bodyPr>
-          <a:lstStyle/>
-          <a:p>
-            <a:pPr algn="l"/>
-            <a:r>
-              <a:rPr sz="1200" b="0">
-                <a:solidFill>
-                  <a:srgbClr val="5A6B6C"/>
-                </a:solidFill>
-                <a:latin typeface="Calibri"/>
-              </a:rPr>
-              <a:t>The Gold star schema is now also written back to Neon Postgres, and Power BI reads public.* tables through the Python connector — no hard-coded local paths.</a:t>
-            </a:r>
-          </a:p>
-        </p:txBody>
-      </p:sp>
-      <p:sp>
-        <p:nvSpPr>
-          <p:cNvPr id="16" name="Rectangle 15"/>
-          <p:cNvSpPr/>
-          <p:nvPr/>
-        </p:nvSpPr>
-        <p:spPr>
-          <a:xfrm>
-            <a:off x="9052560" y="1691640"/>
-            <a:ext cx="2606040" cy="3017520"/>
-          </a:xfrm>
-          <a:prstGeom prst="rect">
-            <a:avLst/>
-          </a:prstGeom>
-          <a:solidFill>
-            <a:srgbClr val="F4F8F8"/>
-          </a:solidFill>
-          <a:ln>
-            <a:noFill/>
-          </a:ln>
-          <a:effectLst/>
-        </p:spPr>
-        <p:style>
-          <a:lnRef idx="1">
-            <a:schemeClr val="accent1"/>
-          </a:lnRef>
-          <a:fillRef idx="3">
-            <a:schemeClr val="accent1"/>
-          </a:fillRef>
-          <a:effectRef idx="2">
-            <a:schemeClr val="accent1"/>
-          </a:effectRef>
-          <a:fontRef idx="minor">
-            <a:schemeClr val="lt1"/>
-          </a:fontRef>
-        </p:style>
-        <p:txBody>
-          <a:bodyPr rtlCol="0" anchor="ctr"/>
-          <a:lstStyle/>
-          <a:p>
-            <a:pPr algn="ctr"/>
-          </a:p>
-        </p:txBody>
-      </p:sp>
-      <p:sp>
-        <p:nvSpPr>
-          <p:cNvPr id="17" name="Rectangle 16"/>
-          <p:cNvSpPr/>
-          <p:nvPr/>
-        </p:nvSpPr>
-        <p:spPr>
-          <a:xfrm>
-            <a:off x="9281160" y="1965960"/>
-            <a:ext cx="502920" cy="502920"/>
-          </a:xfrm>
-          <a:prstGeom prst="rect">
-            <a:avLst/>
-          </a:prstGeom>
-          <a:solidFill>
-            <a:srgbClr val="028090"/>
-          </a:solidFill>
-          <a:ln>
-            <a:noFill/>
-          </a:ln>
-          <a:effectLst/>
-        </p:spPr>
-        <p:style>
-          <a:lnRef idx="1">
-            <a:schemeClr val="accent1"/>
-          </a:lnRef>
-          <a:fillRef idx="3">
-            <a:schemeClr val="accent1"/>
-          </a:fillRef>
-          <a:effectRef idx="2">
-            <a:schemeClr val="accent1"/>
-          </a:effectRef>
-          <a:fontRef idx="minor">
-            <a:schemeClr val="lt1"/>
-          </a:fontRef>
-        </p:style>
-        <p:txBody>
-          <a:bodyPr rtlCol="0" anchor="ctr"/>
-          <a:lstStyle/>
-          <a:p>
-            <a:pPr algn="ctr"/>
-            <a:r>
-              <a:rPr sz="2000" b="1">
-                <a:solidFill>
-                  <a:srgbClr val="FFFFFF"/>
-                </a:solidFill>
-                <a:latin typeface="Cambria"/>
-              </a:rPr>
-              <a:t>4</a:t>
-            </a:r>
-          </a:p>
-        </p:txBody>
-      </p:sp>
-      <p:sp>
-        <p:nvSpPr>
-          <p:cNvPr id="18" name="TextBox 17"/>
-          <p:cNvSpPr txBox="1"/>
-          <p:nvPr/>
-        </p:nvSpPr>
-        <p:spPr>
-          <a:xfrm>
-            <a:off x="9281160" y="2606040"/>
-            <a:ext cx="2148840" cy="365760"/>
-          </a:xfrm>
-          <a:prstGeom prst="rect">
-            <a:avLst/>
-          </a:prstGeom>
-          <a:noFill/>
-        </p:spPr>
-        <p:txBody>
-          <a:bodyPr wrap="square" lIns="0" rIns="0" tIns="0" bIns="0">
-            <a:spAutoFit/>
-          </a:bodyPr>
-          <a:lstStyle/>
-          <a:p>
-            <a:pPr algn="l"/>
-            <a:r>
-              <a:rPr sz="1800" b="1">
-                <a:solidFill>
-                  <a:srgbClr val="1A2E2E"/>
-                </a:solidFill>
-                <a:latin typeface="Cambria"/>
-              </a:rPr>
-              <a:t>Celery + Redis</a:t>
-            </a:r>
-          </a:p>
-        </p:txBody>
-      </p:sp>
-      <p:sp>
-        <p:nvSpPr>
-          <p:cNvPr id="19" name="TextBox 18"/>
-          <p:cNvSpPr txBox="1"/>
-          <p:nvPr/>
-        </p:nvSpPr>
-        <p:spPr>
-          <a:xfrm>
-            <a:off x="9281160" y="3017520"/>
-            <a:ext cx="2148840" cy="1463040"/>
-          </a:xfrm>
-          <a:prstGeom prst="rect">
-            <a:avLst/>
-          </a:prstGeom>
-          <a:noFill/>
-        </p:spPr>
-        <p:txBody>
-          <a:bodyPr wrap="square" lIns="0" rIns="0" tIns="0" bIns="0">
-            <a:spAutoFit/>
-          </a:bodyPr>
-          <a:lstStyle/>
-          <a:p>
-            <a:pPr algn="l"/>
-            <a:r>
-              <a:rPr sz="1200" b="0">
-                <a:solidFill>
-                  <a:srgbClr val="5A6B6C"/>
-                </a:solidFill>
-                <a:latin typeface="Calibri"/>
-              </a:rPr>
-              <a:t>Airflow moved from LocalExecutor to CeleryExecutor with a Redis broker, SMTP alert variables, and a volume-mounted Gold export at /opt/airflow/output.</a:t>
-            </a:r>
-          </a:p>
-        </p:txBody>
-      </p:sp>
-      <p:sp>
-        <p:nvSpPr>
-          <p:cNvPr id="20" name="TextBox 19"/>
-          <p:cNvSpPr txBox="1"/>
-          <p:nvPr/>
-        </p:nvSpPr>
-        <p:spPr>
-          <a:xfrm>
-            <a:off x="548640" y="5029200"/>
-            <a:ext cx="10972800" cy="457200"/>
-          </a:xfrm>
-          <a:prstGeom prst="rect">
-            <a:avLst/>
-          </a:prstGeom>
-          <a:noFill/>
-        </p:spPr>
-        <p:txBody>
-          <a:bodyPr wrap="square" lIns="0" rIns="0" tIns="0" bIns="0">
-            <a:spAutoFit/>
-          </a:bodyPr>
-          <a:lstStyle/>
-          <a:p>
-            <a:pPr algn="l"/>
-            <a:r>
-              <a:rPr sz="1200" b="0">
-                <a:solidFill>
-                  <a:srgbClr val="00A896"/>
-                </a:solidFill>
-                <a:latin typeface="Calibri"/>
-              </a:rPr>
-              <a:t>All report JSON validated  ·  Reconciliation green  ·  48 semantic-model &amp; report files parse cleanly</a:t>
-            </a:r>
-          </a:p>
-        </p:txBody>
-      </p:sp>
-      <p:sp>
-        <p:nvSpPr>
-          <p:cNvPr id="21" name="TextBox 20"/>
-          <p:cNvSpPr txBox="1"/>
-          <p:nvPr/>
-        </p:nvSpPr>
-        <p:spPr>
-          <a:xfrm>
-            <a:off x="548640" y="6537960"/>
-            <a:ext cx="7315200" cy="274320"/>
-          </a:xfrm>
-          <a:prstGeom prst="rect">
-            <a:avLst/>
-          </a:prstGeom>
-          <a:noFill/>
-        </p:spPr>
-        <p:txBody>
-          <a:bodyPr wrap="square" lIns="0" rIns="0" tIns="0" bIns="0">
-            <a:spAutoFit/>
-          </a:bodyPr>
-          <a:lstStyle/>
-          <a:p>
-            <a:pPr algn="l"/>
-            <a:r>
-              <a:rPr sz="900" b="0">
-                <a:solidFill>
-                  <a:srgbClr val="5A6B6C"/>
-                </a:solidFill>
-                <a:latin typeface="Calibri"/>
-              </a:rPr>
-              <a:t>Healthcare Analytics &amp; Lakehouse Platform</a:t>
-            </a:r>
-          </a:p>
-        </p:txBody>
-      </p:sp>
-      <p:sp>
-        <p:nvSpPr>
-          <p:cNvPr id="22" name="TextBox 21"/>
-          <p:cNvSpPr txBox="1"/>
-          <p:nvPr/>
-        </p:nvSpPr>
-        <p:spPr>
-          <a:xfrm>
-            <a:off x="11521440" y="6537960"/>
-            <a:ext cx="457200" cy="274320"/>
-          </a:xfrm>
-          <a:prstGeom prst="rect">
-            <a:avLst/>
-          </a:prstGeom>
-          <a:noFill/>
-        </p:spPr>
-        <p:txBody>
-          <a:bodyPr wrap="square" lIns="0" rIns="0" tIns="0" bIns="0">
-            <a:spAutoFit/>
-          </a:bodyPr>
-          <a:lstStyle/>
-          <a:p>
-            <a:pPr algn="l"/>
-            <a:r>
-              <a:rPr sz="900" b="0">
-                <a:solidFill>
-                  <a:srgbClr val="5A6B6C"/>
-                </a:solidFill>
-                <a:latin typeface="Calibri"/>
-              </a:rPr>
-              <a:t>8</a:t>
-            </a:r>
           </a:p>
         </p:txBody>
       </p:sp>
@@ -10298,6 +9691,867 @@
 </file>
 
 <file path=ppt/slides/slide8.xml><?xml version="1.0" encoding="utf-8"?>
+<p:sld xmlns:a="http://schemas.openxmlformats.org/drawingml/2006/main" xmlns:p="http://schemas.openxmlformats.org/presentationml/2006/main" xmlns:r="http://schemas.openxmlformats.org/officeDocument/2006/relationships">
+  <p:cSld>
+    <p:spTree>
+      <p:nvGrpSpPr>
+        <p:cNvPr id="1" name=""/>
+        <p:cNvGrpSpPr/>
+        <p:nvPr/>
+      </p:nvGrpSpPr>
+      <p:grpSpPr/>
+      <p:sp>
+        <p:nvSpPr>
+          <p:cNvPr id="2" name="TextBox 1"/>
+          <p:cNvSpPr txBox="1"/>
+          <p:nvPr/>
+        </p:nvSpPr>
+        <p:spPr>
+          <a:xfrm>
+            <a:off x="548640" y="365760"/>
+            <a:ext cx="7315200" cy="320040"/>
+          </a:xfrm>
+          <a:prstGeom prst="rect">
+            <a:avLst/>
+          </a:prstGeom>
+          <a:noFill/>
+        </p:spPr>
+        <p:txBody>
+          <a:bodyPr wrap="square" lIns="0" rIns="0" tIns="0" bIns="0">
+            <a:spAutoFit/>
+          </a:bodyPr>
+          <a:lstStyle/>
+          <a:p>
+            <a:pPr algn="l"/>
+            <a:r>
+              <a:rPr sz="1200" b="1">
+                <a:solidFill>
+                  <a:srgbClr val="00A896"/>
+                </a:solidFill>
+                <a:latin typeface="Calibri"/>
+              </a:rPr>
+              <a:t>WHAT'S NEW</a:t>
+            </a:r>
+          </a:p>
+        </p:txBody>
+      </p:sp>
+      <p:sp>
+        <p:nvSpPr>
+          <p:cNvPr id="3" name="TextBox 2"/>
+          <p:cNvSpPr txBox="1"/>
+          <p:nvPr/>
+        </p:nvSpPr>
+        <p:spPr>
+          <a:xfrm>
+            <a:off x="548640" y="640080"/>
+            <a:ext cx="10515600" cy="640080"/>
+          </a:xfrm>
+          <a:prstGeom prst="rect">
+            <a:avLst/>
+          </a:prstGeom>
+          <a:noFill/>
+        </p:spPr>
+        <p:txBody>
+          <a:bodyPr wrap="square" lIns="0" rIns="0" tIns="0" bIns="0">
+            <a:spAutoFit/>
+          </a:bodyPr>
+          <a:lstStyle/>
+          <a:p>
+            <a:pPr algn="l"/>
+            <a:r>
+              <a:rPr sz="3000" b="1">
+                <a:solidFill>
+                  <a:srgbClr val="1A2E2E"/>
+                </a:solidFill>
+                <a:latin typeface="Cambria"/>
+              </a:rPr>
+              <a:t>Updates — October 2026</a:t>
+            </a:r>
+          </a:p>
+        </p:txBody>
+      </p:sp>
+      <p:sp>
+        <p:nvSpPr>
+          <p:cNvPr id="4" name="Rectangle 3"/>
+          <p:cNvSpPr/>
+          <p:nvPr/>
+        </p:nvSpPr>
+        <p:spPr>
+          <a:xfrm>
+            <a:off x="548640" y="1691640"/>
+            <a:ext cx="2606040" cy="3017520"/>
+          </a:xfrm>
+          <a:prstGeom prst="rect">
+            <a:avLst/>
+          </a:prstGeom>
+          <a:solidFill>
+            <a:srgbClr val="F4F8F8"/>
+          </a:solidFill>
+          <a:ln>
+            <a:noFill/>
+          </a:ln>
+          <a:effectLst/>
+        </p:spPr>
+        <p:style>
+          <a:lnRef idx="1">
+            <a:schemeClr val="accent1"/>
+          </a:lnRef>
+          <a:fillRef idx="3">
+            <a:schemeClr val="accent1"/>
+          </a:fillRef>
+          <a:effectRef idx="2">
+            <a:schemeClr val="accent1"/>
+          </a:effectRef>
+          <a:fontRef idx="minor">
+            <a:schemeClr val="lt1"/>
+          </a:fontRef>
+        </p:style>
+        <p:txBody>
+          <a:bodyPr rtlCol="0" anchor="ctr"/>
+          <a:lstStyle/>
+          <a:p>
+            <a:pPr algn="ctr"/>
+          </a:p>
+        </p:txBody>
+      </p:sp>
+      <p:sp>
+        <p:nvSpPr>
+          <p:cNvPr id="5" name="Rectangle 4"/>
+          <p:cNvSpPr/>
+          <p:nvPr/>
+        </p:nvSpPr>
+        <p:spPr>
+          <a:xfrm>
+            <a:off x="777240" y="1965960"/>
+            <a:ext cx="502920" cy="502920"/>
+          </a:xfrm>
+          <a:prstGeom prst="rect">
+            <a:avLst/>
+          </a:prstGeom>
+          <a:solidFill>
+            <a:srgbClr val="028090"/>
+          </a:solidFill>
+          <a:ln>
+            <a:noFill/>
+          </a:ln>
+          <a:effectLst/>
+        </p:spPr>
+        <p:style>
+          <a:lnRef idx="1">
+            <a:schemeClr val="accent1"/>
+          </a:lnRef>
+          <a:fillRef idx="3">
+            <a:schemeClr val="accent1"/>
+          </a:fillRef>
+          <a:effectRef idx="2">
+            <a:schemeClr val="accent1"/>
+          </a:effectRef>
+          <a:fontRef idx="minor">
+            <a:schemeClr val="lt1"/>
+          </a:fontRef>
+        </p:style>
+        <p:txBody>
+          <a:bodyPr rtlCol="0" anchor="ctr"/>
+          <a:lstStyle/>
+          <a:p>
+            <a:pPr algn="ctr"/>
+            <a:r>
+              <a:rPr sz="2000" b="1">
+                <a:solidFill>
+                  <a:srgbClr val="FFFFFF"/>
+                </a:solidFill>
+                <a:latin typeface="Cambria"/>
+              </a:rPr>
+              <a:t>1</a:t>
+            </a:r>
+          </a:p>
+        </p:txBody>
+      </p:sp>
+      <p:sp>
+        <p:nvSpPr>
+          <p:cNvPr id="6" name="TextBox 5"/>
+          <p:cNvSpPr txBox="1"/>
+          <p:nvPr/>
+        </p:nvSpPr>
+        <p:spPr>
+          <a:xfrm>
+            <a:off x="777240" y="2606040"/>
+            <a:ext cx="2148840" cy="365760"/>
+          </a:xfrm>
+          <a:prstGeom prst="rect">
+            <a:avLst/>
+          </a:prstGeom>
+          <a:noFill/>
+        </p:spPr>
+        <p:txBody>
+          <a:bodyPr wrap="square" lIns="0" rIns="0" tIns="0" bIns="0">
+            <a:spAutoFit/>
+          </a:bodyPr>
+          <a:lstStyle/>
+          <a:p>
+            <a:pPr algn="l"/>
+            <a:r>
+              <a:rPr sz="1800" b="1">
+                <a:solidFill>
+                  <a:srgbClr val="1A2E2E"/>
+                </a:solidFill>
+                <a:latin typeface="Cambria"/>
+              </a:rPr>
+              <a:t>Report Redesign</a:t>
+            </a:r>
+          </a:p>
+        </p:txBody>
+      </p:sp>
+      <p:sp>
+        <p:nvSpPr>
+          <p:cNvPr id="7" name="TextBox 6"/>
+          <p:cNvSpPr txBox="1"/>
+          <p:nvPr/>
+        </p:nvSpPr>
+        <p:spPr>
+          <a:xfrm>
+            <a:off x="777240" y="3017520"/>
+            <a:ext cx="2148840" cy="1463040"/>
+          </a:xfrm>
+          <a:prstGeom prst="rect">
+            <a:avLst/>
+          </a:prstGeom>
+          <a:noFill/>
+        </p:spPr>
+        <p:txBody>
+          <a:bodyPr wrap="square" lIns="0" rIns="0" tIns="0" bIns="0">
+            <a:spAutoFit/>
+          </a:bodyPr>
+          <a:lstStyle/>
+          <a:p>
+            <a:pPr algn="l"/>
+            <a:r>
+              <a:rPr sz="1200" b="0">
+                <a:solidFill>
+                  <a:srgbClr val="5A6B6C"/>
+                </a:solidFill>
+                <a:latin typeface="Calibri"/>
+              </a:rPr>
+              <a:t>White branded header on all three pages, a dedicated Filters panel, KPI cards with visible labels, $K data labels, and Refresh / Clear Filters controls.</a:t>
+            </a:r>
+          </a:p>
+        </p:txBody>
+      </p:sp>
+      <p:sp>
+        <p:nvSpPr>
+          <p:cNvPr id="8" name="Rectangle 7"/>
+          <p:cNvSpPr/>
+          <p:nvPr/>
+        </p:nvSpPr>
+        <p:spPr>
+          <a:xfrm>
+            <a:off x="3383280" y="1691640"/>
+            <a:ext cx="2606040" cy="3017520"/>
+          </a:xfrm>
+          <a:prstGeom prst="rect">
+            <a:avLst/>
+          </a:prstGeom>
+          <a:solidFill>
+            <a:srgbClr val="F4F8F8"/>
+          </a:solidFill>
+          <a:ln>
+            <a:noFill/>
+          </a:ln>
+          <a:effectLst/>
+        </p:spPr>
+        <p:style>
+          <a:lnRef idx="1">
+            <a:schemeClr val="accent1"/>
+          </a:lnRef>
+          <a:fillRef idx="3">
+            <a:schemeClr val="accent1"/>
+          </a:fillRef>
+          <a:effectRef idx="2">
+            <a:schemeClr val="accent1"/>
+          </a:effectRef>
+          <a:fontRef idx="minor">
+            <a:schemeClr val="lt1"/>
+          </a:fontRef>
+        </p:style>
+        <p:txBody>
+          <a:bodyPr rtlCol="0" anchor="ctr"/>
+          <a:lstStyle/>
+          <a:p>
+            <a:pPr algn="ctr"/>
+          </a:p>
+        </p:txBody>
+      </p:sp>
+      <p:sp>
+        <p:nvSpPr>
+          <p:cNvPr id="9" name="Rectangle 8"/>
+          <p:cNvSpPr/>
+          <p:nvPr/>
+        </p:nvSpPr>
+        <p:spPr>
+          <a:xfrm>
+            <a:off x="3611880" y="1965960"/>
+            <a:ext cx="502920" cy="502920"/>
+          </a:xfrm>
+          <a:prstGeom prst="rect">
+            <a:avLst/>
+          </a:prstGeom>
+          <a:solidFill>
+            <a:srgbClr val="028090"/>
+          </a:solidFill>
+          <a:ln>
+            <a:noFill/>
+          </a:ln>
+          <a:effectLst/>
+        </p:spPr>
+        <p:style>
+          <a:lnRef idx="1">
+            <a:schemeClr val="accent1"/>
+          </a:lnRef>
+          <a:fillRef idx="3">
+            <a:schemeClr val="accent1"/>
+          </a:fillRef>
+          <a:effectRef idx="2">
+            <a:schemeClr val="accent1"/>
+          </a:effectRef>
+          <a:fontRef idx="minor">
+            <a:schemeClr val="lt1"/>
+          </a:fontRef>
+        </p:style>
+        <p:txBody>
+          <a:bodyPr rtlCol="0" anchor="ctr"/>
+          <a:lstStyle/>
+          <a:p>
+            <a:pPr algn="ctr"/>
+            <a:r>
+              <a:rPr sz="2000" b="1">
+                <a:solidFill>
+                  <a:srgbClr val="FFFFFF"/>
+                </a:solidFill>
+                <a:latin typeface="Cambria"/>
+              </a:rPr>
+              <a:t>2</a:t>
+            </a:r>
+          </a:p>
+        </p:txBody>
+      </p:sp>
+      <p:sp>
+        <p:nvSpPr>
+          <p:cNvPr id="10" name="TextBox 9"/>
+          <p:cNvSpPr txBox="1"/>
+          <p:nvPr/>
+        </p:nvSpPr>
+        <p:spPr>
+          <a:xfrm>
+            <a:off x="3611880" y="2606040"/>
+            <a:ext cx="2148840" cy="365760"/>
+          </a:xfrm>
+          <a:prstGeom prst="rect">
+            <a:avLst/>
+          </a:prstGeom>
+          <a:noFill/>
+        </p:spPr>
+        <p:txBody>
+          <a:bodyPr wrap="square" lIns="0" rIns="0" tIns="0" bIns="0">
+            <a:spAutoFit/>
+          </a:bodyPr>
+          <a:lstStyle/>
+          <a:p>
+            <a:pPr algn="l"/>
+            <a:r>
+              <a:rPr sz="1800" b="1">
+                <a:solidFill>
+                  <a:srgbClr val="1A2E2E"/>
+                </a:solidFill>
+                <a:latin typeface="Cambria"/>
+              </a:rPr>
+              <a:t>Live Refresh Stamp</a:t>
+            </a:r>
+          </a:p>
+        </p:txBody>
+      </p:sp>
+      <p:sp>
+        <p:nvSpPr>
+          <p:cNvPr id="11" name="TextBox 10"/>
+          <p:cNvSpPr txBox="1"/>
+          <p:nvPr/>
+        </p:nvSpPr>
+        <p:spPr>
+          <a:xfrm>
+            <a:off x="3611880" y="3017520"/>
+            <a:ext cx="2148840" cy="1463040"/>
+          </a:xfrm>
+          <a:prstGeom prst="rect">
+            <a:avLst/>
+          </a:prstGeom>
+          <a:noFill/>
+        </p:spPr>
+        <p:txBody>
+          <a:bodyPr wrap="square" lIns="0" rIns="0" tIns="0" bIns="0">
+            <a:spAutoFit/>
+          </a:bodyPr>
+          <a:lstStyle/>
+          <a:p>
+            <a:pPr algn="l"/>
+            <a:r>
+              <a:rPr sz="1200" b="0">
+                <a:solidFill>
+                  <a:srgbClr val="5A6B6C"/>
+                </a:solidFill>
+                <a:latin typeface="Calibri"/>
+              </a:rPr>
+              <a:t>A new 'Data Last Refreshed' DAX measure (FORMAT(NOW())) replaces the static timestamp and updates automatically on every model refresh.</a:t>
+            </a:r>
+          </a:p>
+        </p:txBody>
+      </p:sp>
+      <p:sp>
+        <p:nvSpPr>
+          <p:cNvPr id="12" name="Rectangle 11"/>
+          <p:cNvSpPr/>
+          <p:nvPr/>
+        </p:nvSpPr>
+        <p:spPr>
+          <a:xfrm>
+            <a:off x="6217920" y="1691640"/>
+            <a:ext cx="2606040" cy="3017520"/>
+          </a:xfrm>
+          <a:prstGeom prst="rect">
+            <a:avLst/>
+          </a:prstGeom>
+          <a:solidFill>
+            <a:srgbClr val="F4F8F8"/>
+          </a:solidFill>
+          <a:ln>
+            <a:noFill/>
+          </a:ln>
+          <a:effectLst/>
+        </p:spPr>
+        <p:style>
+          <a:lnRef idx="1">
+            <a:schemeClr val="accent1"/>
+          </a:lnRef>
+          <a:fillRef idx="3">
+            <a:schemeClr val="accent1"/>
+          </a:fillRef>
+          <a:effectRef idx="2">
+            <a:schemeClr val="accent1"/>
+          </a:effectRef>
+          <a:fontRef idx="minor">
+            <a:schemeClr val="lt1"/>
+          </a:fontRef>
+        </p:style>
+        <p:txBody>
+          <a:bodyPr rtlCol="0" anchor="ctr"/>
+          <a:lstStyle/>
+          <a:p>
+            <a:pPr algn="ctr"/>
+          </a:p>
+        </p:txBody>
+      </p:sp>
+      <p:sp>
+        <p:nvSpPr>
+          <p:cNvPr id="13" name="Rectangle 12"/>
+          <p:cNvSpPr/>
+          <p:nvPr/>
+        </p:nvSpPr>
+        <p:spPr>
+          <a:xfrm>
+            <a:off x="6446520" y="1965960"/>
+            <a:ext cx="502920" cy="502920"/>
+          </a:xfrm>
+          <a:prstGeom prst="rect">
+            <a:avLst/>
+          </a:prstGeom>
+          <a:solidFill>
+            <a:srgbClr val="028090"/>
+          </a:solidFill>
+          <a:ln>
+            <a:noFill/>
+          </a:ln>
+          <a:effectLst/>
+        </p:spPr>
+        <p:style>
+          <a:lnRef idx="1">
+            <a:schemeClr val="accent1"/>
+          </a:lnRef>
+          <a:fillRef idx="3">
+            <a:schemeClr val="accent1"/>
+          </a:fillRef>
+          <a:effectRef idx="2">
+            <a:schemeClr val="accent1"/>
+          </a:effectRef>
+          <a:fontRef idx="minor">
+            <a:schemeClr val="lt1"/>
+          </a:fontRef>
+        </p:style>
+        <p:txBody>
+          <a:bodyPr rtlCol="0" anchor="ctr"/>
+          <a:lstStyle/>
+          <a:p>
+            <a:pPr algn="ctr"/>
+            <a:r>
+              <a:rPr sz="2000" b="1">
+                <a:solidFill>
+                  <a:srgbClr val="FFFFFF"/>
+                </a:solidFill>
+                <a:latin typeface="Cambria"/>
+              </a:rPr>
+              <a:t>3</a:t>
+            </a:r>
+          </a:p>
+        </p:txBody>
+      </p:sp>
+      <p:sp>
+        <p:nvSpPr>
+          <p:cNvPr id="14" name="TextBox 13"/>
+          <p:cNvSpPr txBox="1"/>
+          <p:nvPr/>
+        </p:nvSpPr>
+        <p:spPr>
+          <a:xfrm>
+            <a:off x="6446520" y="2606040"/>
+            <a:ext cx="2148840" cy="365760"/>
+          </a:xfrm>
+          <a:prstGeom prst="rect">
+            <a:avLst/>
+          </a:prstGeom>
+          <a:noFill/>
+        </p:spPr>
+        <p:txBody>
+          <a:bodyPr wrap="square" lIns="0" rIns="0" tIns="0" bIns="0">
+            <a:spAutoFit/>
+          </a:bodyPr>
+          <a:lstStyle/>
+          <a:p>
+            <a:pPr algn="l"/>
+            <a:r>
+              <a:rPr sz="1800" b="1">
+                <a:solidFill>
+                  <a:srgbClr val="1A2E2E"/>
+                </a:solidFill>
+                <a:latin typeface="Cambria"/>
+              </a:rPr>
+              <a:t>Gold → Neon Serving</a:t>
+            </a:r>
+          </a:p>
+        </p:txBody>
+      </p:sp>
+      <p:sp>
+        <p:nvSpPr>
+          <p:cNvPr id="15" name="TextBox 14"/>
+          <p:cNvSpPr txBox="1"/>
+          <p:nvPr/>
+        </p:nvSpPr>
+        <p:spPr>
+          <a:xfrm>
+            <a:off x="6446520" y="3017520"/>
+            <a:ext cx="2148840" cy="1463040"/>
+          </a:xfrm>
+          <a:prstGeom prst="rect">
+            <a:avLst/>
+          </a:prstGeom>
+          <a:noFill/>
+        </p:spPr>
+        <p:txBody>
+          <a:bodyPr wrap="square" lIns="0" rIns="0" tIns="0" bIns="0">
+            <a:spAutoFit/>
+          </a:bodyPr>
+          <a:lstStyle/>
+          <a:p>
+            <a:pPr algn="l"/>
+            <a:r>
+              <a:rPr sz="1200" b="0">
+                <a:solidFill>
+                  <a:srgbClr val="5A6B6C"/>
+                </a:solidFill>
+                <a:latin typeface="Calibri"/>
+              </a:rPr>
+              <a:t>The Gold star schema is now also written back to Neon Postgres, and Power BI reads public.* tables through the Python connector — no hard-coded local paths.</a:t>
+            </a:r>
+          </a:p>
+        </p:txBody>
+      </p:sp>
+      <p:sp>
+        <p:nvSpPr>
+          <p:cNvPr id="16" name="Rectangle 15"/>
+          <p:cNvSpPr/>
+          <p:nvPr/>
+        </p:nvSpPr>
+        <p:spPr>
+          <a:xfrm>
+            <a:off x="9052560" y="1691640"/>
+            <a:ext cx="2606040" cy="3017520"/>
+          </a:xfrm>
+          <a:prstGeom prst="rect">
+            <a:avLst/>
+          </a:prstGeom>
+          <a:solidFill>
+            <a:srgbClr val="F4F8F8"/>
+          </a:solidFill>
+          <a:ln>
+            <a:noFill/>
+          </a:ln>
+          <a:effectLst/>
+        </p:spPr>
+        <p:style>
+          <a:lnRef idx="1">
+            <a:schemeClr val="accent1"/>
+          </a:lnRef>
+          <a:fillRef idx="3">
+            <a:schemeClr val="accent1"/>
+          </a:fillRef>
+          <a:effectRef idx="2">
+            <a:schemeClr val="accent1"/>
+          </a:effectRef>
+          <a:fontRef idx="minor">
+            <a:schemeClr val="lt1"/>
+          </a:fontRef>
+        </p:style>
+        <p:txBody>
+          <a:bodyPr rtlCol="0" anchor="ctr"/>
+          <a:lstStyle/>
+          <a:p>
+            <a:pPr algn="ctr"/>
+          </a:p>
+        </p:txBody>
+      </p:sp>
+      <p:sp>
+        <p:nvSpPr>
+          <p:cNvPr id="17" name="Rectangle 16"/>
+          <p:cNvSpPr/>
+          <p:nvPr/>
+        </p:nvSpPr>
+        <p:spPr>
+          <a:xfrm>
+            <a:off x="9281160" y="1965960"/>
+            <a:ext cx="502920" cy="502920"/>
+          </a:xfrm>
+          <a:prstGeom prst="rect">
+            <a:avLst/>
+          </a:prstGeom>
+          <a:solidFill>
+            <a:srgbClr val="028090"/>
+          </a:solidFill>
+          <a:ln>
+            <a:noFill/>
+          </a:ln>
+          <a:effectLst/>
+        </p:spPr>
+        <p:style>
+          <a:lnRef idx="1">
+            <a:schemeClr val="accent1"/>
+          </a:lnRef>
+          <a:fillRef idx="3">
+            <a:schemeClr val="accent1"/>
+          </a:fillRef>
+          <a:effectRef idx="2">
+            <a:schemeClr val="accent1"/>
+          </a:effectRef>
+          <a:fontRef idx="minor">
+            <a:schemeClr val="lt1"/>
+          </a:fontRef>
+        </p:style>
+        <p:txBody>
+          <a:bodyPr rtlCol="0" anchor="ctr"/>
+          <a:lstStyle/>
+          <a:p>
+            <a:pPr algn="ctr"/>
+            <a:r>
+              <a:rPr sz="2000" b="1">
+                <a:solidFill>
+                  <a:srgbClr val="FFFFFF"/>
+                </a:solidFill>
+                <a:latin typeface="Cambria"/>
+              </a:rPr>
+              <a:t>4</a:t>
+            </a:r>
+          </a:p>
+        </p:txBody>
+      </p:sp>
+      <p:sp>
+        <p:nvSpPr>
+          <p:cNvPr id="18" name="TextBox 17"/>
+          <p:cNvSpPr txBox="1"/>
+          <p:nvPr/>
+        </p:nvSpPr>
+        <p:spPr>
+          <a:xfrm>
+            <a:off x="9281160" y="2606040"/>
+            <a:ext cx="2148840" cy="365760"/>
+          </a:xfrm>
+          <a:prstGeom prst="rect">
+            <a:avLst/>
+          </a:prstGeom>
+          <a:noFill/>
+        </p:spPr>
+        <p:txBody>
+          <a:bodyPr wrap="square" lIns="0" rIns="0" tIns="0" bIns="0">
+            <a:spAutoFit/>
+          </a:bodyPr>
+          <a:lstStyle/>
+          <a:p>
+            <a:pPr algn="l"/>
+            <a:r>
+              <a:rPr sz="1800" b="1">
+                <a:solidFill>
+                  <a:srgbClr val="1A2E2E"/>
+                </a:solidFill>
+                <a:latin typeface="Cambria"/>
+              </a:rPr>
+              <a:t>Celery + Redis</a:t>
+            </a:r>
+          </a:p>
+        </p:txBody>
+      </p:sp>
+      <p:sp>
+        <p:nvSpPr>
+          <p:cNvPr id="19" name="TextBox 18"/>
+          <p:cNvSpPr txBox="1"/>
+          <p:nvPr/>
+        </p:nvSpPr>
+        <p:spPr>
+          <a:xfrm>
+            <a:off x="9281160" y="3017520"/>
+            <a:ext cx="2148840" cy="1463040"/>
+          </a:xfrm>
+          <a:prstGeom prst="rect">
+            <a:avLst/>
+          </a:prstGeom>
+          <a:noFill/>
+        </p:spPr>
+        <p:txBody>
+          <a:bodyPr wrap="square" lIns="0" rIns="0" tIns="0" bIns="0">
+            <a:spAutoFit/>
+          </a:bodyPr>
+          <a:lstStyle/>
+          <a:p>
+            <a:pPr algn="l"/>
+            <a:r>
+              <a:rPr sz="1200" b="0">
+                <a:solidFill>
+                  <a:srgbClr val="5A6B6C"/>
+                </a:solidFill>
+                <a:latin typeface="Calibri"/>
+              </a:rPr>
+              <a:t>Airflow moved from LocalExecutor to CeleryExecutor with a Redis broker, SMTP alert variables, and a volume-mounted Gold export at /opt/airflow/output.</a:t>
+            </a:r>
+          </a:p>
+        </p:txBody>
+      </p:sp>
+      <p:sp>
+        <p:nvSpPr>
+          <p:cNvPr id="20" name="TextBox 19"/>
+          <p:cNvSpPr txBox="1"/>
+          <p:nvPr/>
+        </p:nvSpPr>
+        <p:spPr>
+          <a:xfrm>
+            <a:off x="548640" y="5029200"/>
+            <a:ext cx="10972800" cy="457200"/>
+          </a:xfrm>
+          <a:prstGeom prst="rect">
+            <a:avLst/>
+          </a:prstGeom>
+          <a:noFill/>
+        </p:spPr>
+        <p:txBody>
+          <a:bodyPr wrap="square" lIns="0" rIns="0" tIns="0" bIns="0">
+            <a:spAutoFit/>
+          </a:bodyPr>
+          <a:lstStyle/>
+          <a:p>
+            <a:pPr algn="l"/>
+            <a:r>
+              <a:rPr sz="1200" b="0">
+                <a:solidFill>
+                  <a:srgbClr val="00A896"/>
+                </a:solidFill>
+                <a:latin typeface="Calibri"/>
+              </a:rPr>
+              <a:t>All report JSON validated  ·  Reconciliation green  ·  48 semantic-model &amp; report files parse cleanly</a:t>
+            </a:r>
+          </a:p>
+        </p:txBody>
+      </p:sp>
+      <p:sp>
+        <p:nvSpPr>
+          <p:cNvPr id="21" name="TextBox 20"/>
+          <p:cNvSpPr txBox="1"/>
+          <p:nvPr/>
+        </p:nvSpPr>
+        <p:spPr>
+          <a:xfrm>
+            <a:off x="548640" y="6537960"/>
+            <a:ext cx="7315200" cy="274320"/>
+          </a:xfrm>
+          <a:prstGeom prst="rect">
+            <a:avLst/>
+          </a:prstGeom>
+          <a:noFill/>
+        </p:spPr>
+        <p:txBody>
+          <a:bodyPr wrap="square" lIns="0" rIns="0" tIns="0" bIns="0">
+            <a:spAutoFit/>
+          </a:bodyPr>
+          <a:lstStyle/>
+          <a:p>
+            <a:pPr algn="l"/>
+            <a:r>
+              <a:rPr sz="900" b="0">
+                <a:solidFill>
+                  <a:srgbClr val="5A6B6C"/>
+                </a:solidFill>
+                <a:latin typeface="Calibri"/>
+              </a:rPr>
+              <a:t>Healthcare Analytics &amp; Lakehouse Platform</a:t>
+            </a:r>
+          </a:p>
+        </p:txBody>
+      </p:sp>
+      <p:sp>
+        <p:nvSpPr>
+          <p:cNvPr id="22" name="TextBox 21"/>
+          <p:cNvSpPr txBox="1"/>
+          <p:nvPr/>
+        </p:nvSpPr>
+        <p:spPr>
+          <a:xfrm>
+            <a:off x="11521440" y="6537960"/>
+            <a:ext cx="457200" cy="274320"/>
+          </a:xfrm>
+          <a:prstGeom prst="rect">
+            <a:avLst/>
+          </a:prstGeom>
+          <a:noFill/>
+        </p:spPr>
+        <p:txBody>
+          <a:bodyPr wrap="square" lIns="0" rIns="0" tIns="0" bIns="0">
+            <a:spAutoFit/>
+          </a:bodyPr>
+          <a:lstStyle/>
+          <a:p>
+            <a:pPr algn="l"/>
+            <a:r>
+              <a:rPr sz="900" b="0">
+                <a:solidFill>
+                  <a:srgbClr val="5A6B6C"/>
+                </a:solidFill>
+                <a:latin typeface="Calibri"/>
+              </a:rPr>
+              <a:t>8</a:t>
+            </a:r>
+          </a:p>
+        </p:txBody>
+      </p:sp>
+    </p:spTree>
+  </p:cSld>
+  <p:clrMapOvr>
+    <a:masterClrMapping/>
+  </p:clrMapOvr>
+</p:sld>
+</file>
+
+<file path=ppt/slides/slide9.xml><?xml version="1.0" encoding="utf-8"?>
 <p:sld xmlns:a="http://schemas.openxmlformats.org/drawingml/2006/main" xmlns:r="http://schemas.openxmlformats.org/officeDocument/2006/relationships" xmlns:p="http://schemas.openxmlformats.org/presentationml/2006/main">
   <p:cSld name="Slide 8">
     <p:bg>
@@ -10441,362 +10695,108 @@
           </a:p>
         </p:txBody>
       </p:sp>
+      <p:sp>
+        <p:nvSpPr>
+          <p:cNvPr id="6" name="Text 3"/>
+          <p:cNvSpPr txBox="1"/>
+          <p:nvPr/>
+        </p:nvSpPr>
+        <p:spPr>
+          <a:xfrm>
+            <a:off x="548640" y="6537960"/>
+            <a:ext cx="7315200" cy="274320"/>
+          </a:xfrm>
+          <a:prstGeom prst="rect">
+            <a:avLst/>
+          </a:prstGeom>
+          <a:noFill/>
+          <a:ln/>
+        </p:spPr>
+        <p:txBody>
+          <a:bodyPr wrap="square" rtlCol="0" anchor="ctr"/>
+          <a:lstStyle/>
+          <a:p>
+            <a:pPr marL="0" indent="0">
+              <a:buNone/>
+            </a:pPr>
+            <a:r>
+              <a:rPr lang="en-US" sz="900" dirty="0">
+                <a:solidFill>
+                  <a:srgbClr val="5A6B6C"/>
+                </a:solidFill>
+                <a:latin typeface="Calibri" pitchFamily="34" charset="0"/>
+                <a:ea typeface="Calibri" pitchFamily="34" charset="-122"/>
+                <a:cs typeface="Calibri" pitchFamily="34" charset="-120"/>
+              </a:rPr>
+              <a:t>Healthcare Analytics &amp; Lakehouse Platform</a:t>
+            </a:r>
+            <a:endParaRPr lang="en-US" sz="900" dirty="0"/>
+          </a:p>
+        </p:txBody>
+      </p:sp>
+      <p:sp>
+        <p:nvSpPr>
+          <p:cNvPr id="7" name="Text 4"/>
+          <p:cNvSpPr txBox="1"/>
+          <p:nvPr/>
+        </p:nvSpPr>
+        <p:spPr>
+          <a:xfrm>
+            <a:off x="11521440" y="6537960"/>
+            <a:ext cx="457200" cy="274320"/>
+          </a:xfrm>
+          <a:prstGeom prst="rect">
+            <a:avLst/>
+          </a:prstGeom>
+          <a:noFill/>
+          <a:ln/>
+        </p:spPr>
+        <p:txBody>
+          <a:bodyPr wrap="square" rtlCol="0" anchor="ctr"/>
+          <a:lstStyle/>
+          <a:p>
+            <a:pPr marL="0" indent="0" algn="r">
+              <a:buNone/>
+            </a:pPr>
+            <a:r>
+              <a:rPr lang="en-US" sz="900" dirty="0">
+                <a:solidFill>
+                  <a:srgbClr val="5A6B6C"/>
+                </a:solidFill>
+                <a:latin typeface="Calibri" pitchFamily="34" charset="0"/>
+                <a:ea typeface="Calibri" pitchFamily="34" charset="-122"/>
+                <a:cs typeface="Calibri" pitchFamily="34" charset="-120"/>
+              </a:rPr>
+              <a:t>9</a:t>
+            </a:r>
+            <a:endParaRPr lang="en-US" sz="900" dirty="0"/>
+          </a:p>
+        </p:txBody>
+      </p:sp>
       <p:pic>
         <p:nvPicPr>
-          <p:cNvPr id="5" name="Image 0" descr="assets/dashboard_page1_executive.png"/>
+          <p:cNvPr id="8" name="Picture 7" descr="dashboard_page1_executive.png"/>
           <p:cNvPicPr>
             <a:picLocks noChangeAspect="1"/>
           </p:cNvPicPr>
           <p:nvPr/>
         </p:nvPicPr>
         <p:blipFill>
-          <a:blip r:embed="rId3"/>
+          <a:blip r:embed="rId4"/>
           <a:stretch>
             <a:fillRect/>
           </a:stretch>
         </p:blipFill>
         <p:spPr>
           <a:xfrm>
-            <a:off x="685800" y="1783080"/>
-            <a:ext cx="10835640" cy="4251960"/>
+            <a:off x="2297785" y="1783080"/>
+            <a:ext cx="7611669" cy="4251960"/>
           </a:xfrm>
           <a:prstGeom prst="rect">
             <a:avLst/>
           </a:prstGeom>
         </p:spPr>
       </p:pic>
-      <p:sp>
-        <p:nvSpPr>
-          <p:cNvPr id="6" name="Text 3"/>
-          <p:cNvSpPr txBox="1"/>
-          <p:nvPr/>
-        </p:nvSpPr>
-        <p:spPr>
-          <a:xfrm>
-            <a:off x="548640" y="6537960"/>
-            <a:ext cx="7315200" cy="274320"/>
-          </a:xfrm>
-          <a:prstGeom prst="rect">
-            <a:avLst/>
-          </a:prstGeom>
-          <a:noFill/>
-          <a:ln/>
-        </p:spPr>
-        <p:txBody>
-          <a:bodyPr wrap="square" rtlCol="0" anchor="ctr"/>
-          <a:lstStyle/>
-          <a:p>
-            <a:pPr marL="0" indent="0">
-              <a:buNone/>
-            </a:pPr>
-            <a:r>
-              <a:rPr lang="en-US" sz="900" dirty="0">
-                <a:solidFill>
-                  <a:srgbClr val="5A6B6C"/>
-                </a:solidFill>
-                <a:latin typeface="Calibri" pitchFamily="34" charset="0"/>
-                <a:ea typeface="Calibri" pitchFamily="34" charset="-122"/>
-                <a:cs typeface="Calibri" pitchFamily="34" charset="-120"/>
-              </a:rPr>
-              <a:t>Healthcare Analytics &amp; Lakehouse Platform</a:t>
-            </a:r>
-            <a:endParaRPr lang="en-US" sz="900" dirty="0"/>
-          </a:p>
-        </p:txBody>
-      </p:sp>
-      <p:sp>
-        <p:nvSpPr>
-          <p:cNvPr id="7" name="Text 4"/>
-          <p:cNvSpPr txBox="1"/>
-          <p:nvPr/>
-        </p:nvSpPr>
-        <p:spPr>
-          <a:xfrm>
-            <a:off x="11521440" y="6537960"/>
-            <a:ext cx="457200" cy="274320"/>
-          </a:xfrm>
-          <a:prstGeom prst="rect">
-            <a:avLst/>
-          </a:prstGeom>
-          <a:noFill/>
-          <a:ln/>
-        </p:spPr>
-        <p:txBody>
-          <a:bodyPr wrap="square" rtlCol="0" anchor="ctr"/>
-          <a:lstStyle/>
-          <a:p>
-            <a:pPr marL="0" indent="0" algn="r">
-              <a:buNone/>
-            </a:pPr>
-            <a:r>
-              <a:rPr lang="en-US" sz="900" dirty="0">
-                <a:solidFill>
-                  <a:srgbClr val="5A6B6C"/>
-                </a:solidFill>
-                <a:latin typeface="Calibri" pitchFamily="34" charset="0"/>
-                <a:ea typeface="Calibri" pitchFamily="34" charset="-122"/>
-                <a:cs typeface="Calibri" pitchFamily="34" charset="-120"/>
-              </a:rPr>
-              <a:t>9</a:t>
-            </a:r>
-            <a:endParaRPr lang="en-US" sz="900" dirty="0"/>
-          </a:p>
-        </p:txBody>
-      </p:sp>
-    </p:spTree>
-  </p:cSld>
-  <p:clrMapOvr>
-    <a:masterClrMapping/>
-  </p:clrMapOvr>
-</p:sld>
-</file>
-
-<file path=ppt/slides/slide9.xml><?xml version="1.0" encoding="utf-8"?>
-<p:sld xmlns:a="http://schemas.openxmlformats.org/drawingml/2006/main" xmlns:r="http://schemas.openxmlformats.org/officeDocument/2006/relationships" xmlns:p="http://schemas.openxmlformats.org/presentationml/2006/main">
-  <p:cSld name="Slide 9">
-    <p:bg>
-      <p:bgPr>
-        <a:solidFill>
-          <a:srgbClr val="FFFFFF"/>
-        </a:solidFill>
-        <a:effectLst/>
-      </p:bgPr>
-    </p:bg>
-    <p:spTree>
-      <p:nvGrpSpPr>
-        <p:cNvPr id="1" name=""/>
-        <p:cNvGrpSpPr/>
-        <p:nvPr/>
-      </p:nvGrpSpPr>
-      <p:grpSpPr>
-        <a:xfrm>
-          <a:off x="0" y="0"/>
-          <a:ext cx="0" cy="0"/>
-          <a:chOff x="0" y="0"/>
-          <a:chExt cx="0" cy="0"/>
-        </a:xfrm>
-      </p:grpSpPr>
-      <p:sp>
-        <p:nvSpPr>
-          <p:cNvPr id="2" name="Text 0"/>
-          <p:cNvSpPr txBox="1"/>
-          <p:nvPr/>
-        </p:nvSpPr>
-        <p:spPr>
-          <a:xfrm>
-            <a:off x="548640" y="365760"/>
-            <a:ext cx="7315200" cy="320040"/>
-          </a:xfrm>
-          <a:prstGeom prst="rect">
-            <a:avLst/>
-          </a:prstGeom>
-          <a:noFill/>
-          <a:ln/>
-        </p:spPr>
-        <p:txBody>
-          <a:bodyPr wrap="square" rtlCol="0" anchor="ctr"/>
-          <a:lstStyle/>
-          <a:p>
-            <a:pPr marL="0" indent="0">
-              <a:buNone/>
-            </a:pPr>
-            <a:r>
-              <a:rPr lang="en-US" sz="1200" b="1" kern="0" spc="200" dirty="0">
-                <a:solidFill>
-                  <a:srgbClr val="00A896"/>
-                </a:solidFill>
-                <a:latin typeface="Calibri" pitchFamily="34" charset="0"/>
-                <a:ea typeface="Calibri" pitchFamily="34" charset="-122"/>
-                <a:cs typeface="Calibri" pitchFamily="34" charset="-120"/>
-              </a:rPr>
-              <a:t>POWER BI — PAGE 2</a:t>
-            </a:r>
-            <a:endParaRPr lang="en-US" sz="1200" dirty="0"/>
-          </a:p>
-        </p:txBody>
-      </p:sp>
-      <p:sp>
-        <p:nvSpPr>
-          <p:cNvPr id="3" name="Text 1"/>
-          <p:cNvSpPr txBox="1"/>
-          <p:nvPr/>
-        </p:nvSpPr>
-        <p:spPr>
-          <a:xfrm>
-            <a:off x="548640" y="640080"/>
-            <a:ext cx="10515600" cy="640080"/>
-          </a:xfrm>
-          <a:prstGeom prst="rect">
-            <a:avLst/>
-          </a:prstGeom>
-          <a:noFill/>
-          <a:ln/>
-        </p:spPr>
-        <p:txBody>
-          <a:bodyPr wrap="square" rtlCol="0" anchor="ctr"/>
-          <a:lstStyle/>
-          <a:p>
-            <a:pPr marL="0" indent="0">
-              <a:buNone/>
-            </a:pPr>
-            <a:r>
-              <a:rPr lang="en-US" sz="3000" b="1" dirty="0">
-                <a:solidFill>
-                  <a:srgbClr val="1A2E2E"/>
-                </a:solidFill>
-                <a:latin typeface="Cambria" pitchFamily="34" charset="0"/>
-                <a:ea typeface="Cambria" pitchFamily="34" charset="-122"/>
-                <a:cs typeface="Cambria" pitchFamily="34" charset="-120"/>
-              </a:rPr>
-              <a:t>Financial Integrity &amp; Billing Operations</a:t>
-            </a:r>
-            <a:endParaRPr lang="en-US" sz="3000" dirty="0"/>
-          </a:p>
-        </p:txBody>
-      </p:sp>
-      <p:sp>
-        <p:nvSpPr>
-          <p:cNvPr id="4" name="Shape 2"/>
-          <p:cNvSpPr/>
-          <p:nvPr/>
-        </p:nvSpPr>
-        <p:spPr>
-          <a:xfrm>
-            <a:off x="502920" y="1600200"/>
-            <a:ext cx="11201400" cy="4617720"/>
-          </a:xfrm>
-          <a:prstGeom prst="roundRect">
-            <a:avLst>
-              <a:gd name="adj" fmla="val 792"/>
-            </a:avLst>
-          </a:prstGeom>
-          <a:solidFill>
-            <a:srgbClr val="FFFFFF"/>
-          </a:solidFill>
-          <a:ln w="19050">
-            <a:solidFill>
-              <a:srgbClr val="DCE9E9"/>
-            </a:solidFill>
-            <a:prstDash val="solid"/>
-          </a:ln>
-          <a:effectLst>
-            <a:outerShdw blurRad="101600" dist="38100" dir="5400000" algn="bl" rotWithShape="0">
-              <a:srgbClr val="1A2E2E">
-                <a:alpha val="18000"/>
-              </a:srgbClr>
-            </a:outerShdw>
-          </a:effectLst>
-        </p:spPr>
-        <p:txBody>
-          <a:bodyPr/>
-          <a:lstStyle/>
-          <a:p>
-            <a:endParaRPr lang="en-US"/>
-          </a:p>
-        </p:txBody>
-      </p:sp>
-      <p:pic>
-        <p:nvPicPr>
-          <p:cNvPr id="5" name="Image 0" descr="assets/dashboard_page2_financial.png"/>
-          <p:cNvPicPr>
-            <a:picLocks noChangeAspect="1"/>
-          </p:cNvPicPr>
-          <p:nvPr/>
-        </p:nvPicPr>
-        <p:blipFill>
-          <a:blip r:embed="rId3"/>
-          <a:stretch>
-            <a:fillRect/>
-          </a:stretch>
-        </p:blipFill>
-        <p:spPr>
-          <a:xfrm>
-            <a:off x="685800" y="1783080"/>
-            <a:ext cx="10835640" cy="4251960"/>
-          </a:xfrm>
-          <a:prstGeom prst="rect">
-            <a:avLst/>
-          </a:prstGeom>
-        </p:spPr>
-      </p:pic>
-      <p:sp>
-        <p:nvSpPr>
-          <p:cNvPr id="6" name="Text 3"/>
-          <p:cNvSpPr txBox="1"/>
-          <p:nvPr/>
-        </p:nvSpPr>
-        <p:spPr>
-          <a:xfrm>
-            <a:off x="548640" y="6537960"/>
-            <a:ext cx="7315200" cy="274320"/>
-          </a:xfrm>
-          <a:prstGeom prst="rect">
-            <a:avLst/>
-          </a:prstGeom>
-          <a:noFill/>
-          <a:ln/>
-        </p:spPr>
-        <p:txBody>
-          <a:bodyPr wrap="square" rtlCol="0" anchor="ctr"/>
-          <a:lstStyle/>
-          <a:p>
-            <a:pPr marL="0" indent="0">
-              <a:buNone/>
-            </a:pPr>
-            <a:r>
-              <a:rPr lang="en-US" sz="900" dirty="0">
-                <a:solidFill>
-                  <a:srgbClr val="5A6B6C"/>
-                </a:solidFill>
-                <a:latin typeface="Calibri" pitchFamily="34" charset="0"/>
-                <a:ea typeface="Calibri" pitchFamily="34" charset="-122"/>
-                <a:cs typeface="Calibri" pitchFamily="34" charset="-120"/>
-              </a:rPr>
-              <a:t>Healthcare Analytics &amp; Lakehouse Platform</a:t>
-            </a:r>
-            <a:endParaRPr lang="en-US" sz="900" dirty="0"/>
-          </a:p>
-        </p:txBody>
-      </p:sp>
-      <p:sp>
-        <p:nvSpPr>
-          <p:cNvPr id="7" name="Text 4"/>
-          <p:cNvSpPr txBox="1"/>
-          <p:nvPr/>
-        </p:nvSpPr>
-        <p:spPr>
-          <a:xfrm>
-            <a:off x="11521440" y="6537960"/>
-            <a:ext cx="457200" cy="274320"/>
-          </a:xfrm>
-          <a:prstGeom prst="rect">
-            <a:avLst/>
-          </a:prstGeom>
-          <a:noFill/>
-          <a:ln/>
-        </p:spPr>
-        <p:txBody>
-          <a:bodyPr wrap="square" rtlCol="0" anchor="ctr"/>
-          <a:lstStyle/>
-          <a:p>
-            <a:pPr marL="0" indent="0" algn="r">
-              <a:buNone/>
-            </a:pPr>
-            <a:r>
-              <a:rPr lang="en-US" sz="900" dirty="0">
-                <a:solidFill>
-                  <a:srgbClr val="5A6B6C"/>
-                </a:solidFill>
-                <a:latin typeface="Calibri" pitchFamily="34" charset="0"/>
-                <a:ea typeface="Calibri" pitchFamily="34" charset="-122"/>
-                <a:cs typeface="Calibri" pitchFamily="34" charset="-120"/>
-              </a:rPr>
-              <a:t>10</a:t>
-            </a:r>
-            <a:endParaRPr lang="en-US" sz="900" dirty="0"/>
-          </a:p>
-        </p:txBody>
-      </p:sp>
     </p:spTree>
   </p:cSld>
   <p:clrMapOvr>

</xml_diff>